<commit_message>
Drop presenter notes; point Pages at beyondlatent
</commit_message>
<xml_diff>
--- a/Display-AI-Briefing-SDV-DSC.pptx
+++ b/Display-AI-Briefing-SDV-DSC.pptx
@@ -19758,7 +19758,7 @@
                 <a:latin typeface="Calibri"/>
                 <a:ea typeface="Calibri"/>
               </a:rPr>
-              <a:t>Last: Qwen, Kimi, GLM — not a public chatbot</a:t>
+              <a:t>Qwen, Kimi, GLM — not a public chatbot</a:t>
             </a:r>
           </a:p>
         </p:txBody>
@@ -24633,7 +24633,7 @@
                 <a:latin typeface="Calibri"/>
                 <a:ea typeface="Calibri"/>
               </a:rPr>
-              <a:t>Thirty minutes, then the original pages</a:t>
+              <a:t>Sections</a:t>
             </a:r>
           </a:p>
         </p:txBody>
@@ -24676,7 +24676,7 @@
                 <a:latin typeface="Calibri"/>
                 <a:ea typeface="Calibri"/>
               </a:rPr>
-              <a:t>•  Short talk: Start → Can / cannot → Generative AI → Playbook → Rules.</a:t>
+              <a:t>•  Start. Can and cannot. Scoring AI versus generative AI.</a:t>
             </a:r>
           </a:p>
           <a:p>
@@ -24696,7 +24696,7 @@
                 <a:latin typeface="Calibri"/>
                 <a:ea typeface="Calibri"/>
               </a:rPr>
-              <a:t>•  Local LLM (Qwen, Kimi, GLM) is last — after you know what not to ask.</a:t>
+              <a:t>•  Map, machine learning, deep learning — how each layer works.</a:t>
             </a:r>
           </a:p>
           <a:p>
@@ -24716,7 +24716,7 @@
                 <a:latin typeface="Calibri"/>
                 <a:ea typeface="Calibri"/>
               </a:rPr>
-              <a:t>•  The original pages stay: Map, ML, DL, Trends, Line.</a:t>
+              <a:t>•  Trends, the line, playbook, rules.</a:t>
             </a:r>
           </a:p>
           <a:p>
@@ -24736,7 +24736,7 @@
                 <a:latin typeface="Calibri"/>
                 <a:ea typeface="Calibri"/>
               </a:rPr>
-              <a:t>•  Do not skip Rules. AI may draft. It may not release.</a:t>
+              <a:t>•  Local LLM last: Qwen, Kimi, GLM. Not a public chatbot.</a:t>
             </a:r>
           </a:p>
         </p:txBody>

</xml_diff>

<commit_message>
Strip remaining presenter notes; keep beyondlatent Pages URL
</commit_message>
<xml_diff>
--- a/Display-AI-Briefing-SDV-DSC.pptx
+++ b/Display-AI-Briefing-SDV-DSC.pptx
@@ -10508,7 +10508,7 @@
                 <a:latin typeface="Calibri"/>
                 <a:ea typeface="Calibri"/>
               </a:rPr>
-              <a:t>Who this talk is for</a:t>
+              <a:t>Who this is for</a:t>
             </a:r>
           </a:p>
         </p:txBody>
@@ -10824,110 +10824,7 @@
       </p:sp>
       <p:sp>
         <p:nvSpPr>
-          <p:cNvPr id="12" name="Rounded Rectangle 11"/>
-          <p:cNvSpPr/>
-          <p:nvPr/>
-        </p:nvSpPr>
-        <p:spPr>
-          <a:xfrm>
-            <a:off x="6172200" y="3877056"/>
-            <a:ext cx="5504688" cy="2295144"/>
-          </a:xfrm>
-          <a:prstGeom prst="roundRect">
-            <a:avLst>
-              <a:gd name="adj" fmla="val 8000"/>
-            </a:avLst>
-          </a:prstGeom>
-          <a:solidFill>
-            <a:srgbClr val="FBFAF6"/>
-          </a:solidFill>
-          <a:ln>
-            <a:noFill/>
-          </a:ln>
-          <a:effectLst/>
-        </p:spPr>
-        <p:style>
-          <a:lnRef idx="1">
-            <a:schemeClr val="accent1"/>
-          </a:lnRef>
-          <a:fillRef idx="3">
-            <a:schemeClr val="accent1"/>
-          </a:fillRef>
-          <a:effectRef idx="2">
-            <a:schemeClr val="accent1"/>
-          </a:effectRef>
-          <a:fontRef idx="minor">
-            <a:schemeClr val="lt1"/>
-          </a:fontRef>
-        </p:style>
-        <p:txBody>
-          <a:bodyPr rtlCol="0" anchor="ctr"/>
-          <a:lstStyle/>
-          <a:p>
-            <a:pPr algn="ctr"/>
-          </a:p>
-        </p:txBody>
-      </p:sp>
-      <p:sp>
-        <p:nvSpPr>
-          <p:cNvPr id="13" name="TextBox 12"/>
-          <p:cNvSpPr txBox="1"/>
-          <p:nvPr/>
-        </p:nvSpPr>
-        <p:spPr>
-          <a:xfrm>
-            <a:off x="6373368" y="4023360"/>
-            <a:ext cx="5138928" cy="2039112"/>
-          </a:xfrm>
-          <a:prstGeom prst="rect">
-            <a:avLst/>
-          </a:prstGeom>
-          <a:noFill/>
-        </p:spPr>
-        <p:txBody>
-          <a:bodyPr wrap="square">
-            <a:spAutoFit/>
-          </a:bodyPr>
-          <a:lstStyle/>
-          <a:p>
-            <a:pPr>
-              <a:spcAft>
-                <a:spcPts val="800"/>
-              </a:spcAft>
-            </a:pPr>
-            <a:r>
-              <a:rPr sz="1500" b="1">
-                <a:solidFill>
-                  <a:srgbClr val="143A8C"/>
-                </a:solidFill>
-                <a:latin typeface="Calibri"/>
-                <a:ea typeface="Calibri"/>
-              </a:rPr>
-              <a:t>Out of scope</a:t>
-            </a:r>
-          </a:p>
-          <a:p>
-            <a:pPr>
-              <a:spcAft>
-                <a:spcPts val="0"/>
-              </a:spcAft>
-            </a:pPr>
-            <a:r>
-              <a:rPr sz="1300" b="0">
-                <a:solidFill>
-                  <a:srgbClr val="5C6370"/>
-                </a:solidFill>
-                <a:latin typeface="Calibri"/>
-                <a:ea typeface="Calibri"/>
-              </a:rPr>
-              <a:t>Model research, vendor bake-offs, GPU capacity. Replacing AOI with a caption.</a:t>
-            </a:r>
-          </a:p>
-        </p:txBody>
-      </p:sp>
-      <p:sp>
-        <p:nvSpPr>
-          <p:cNvPr id="14" name="TextBox 13"/>
+          <p:cNvPr id="12" name="TextBox 11"/>
           <p:cNvSpPr txBox="1"/>
           <p:nvPr/>
         </p:nvSpPr>
@@ -10967,7 +10864,7 @@
       </p:sp>
       <p:sp>
         <p:nvSpPr>
-          <p:cNvPr id="15" name="TextBox 14"/>
+          <p:cNvPr id="13" name="TextBox 12"/>
           <p:cNvSpPr txBox="1"/>
           <p:nvPr/>
         </p:nvSpPr>

</xml_diff>

<commit_message>
Drop SDV/DSC from acronym expansions
</commit_message>
<xml_diff>
--- a/Display-AI-Briefing-SDV-DSC.pptx
+++ b/Display-AI-Briefing-SDV-DSC.pptx
@@ -3374,7 +3374,7 @@
                 <a:latin typeface="Calibri"/>
                 <a:ea typeface="Calibri"/>
               </a:rPr>
-              <a:t>Quality engineers at Samsung Display Vietnam (SDV) and DSC (China site)  ·  not AI researchers</a:t>
+              <a:t>Quality engineers at SDV and DSC  ·  not AI researchers</a:t>
             </a:r>
           </a:p>
           <a:p>
@@ -11290,7 +11290,7 @@
                 <a:latin typeface="Calibri"/>
                 <a:ea typeface="Calibri"/>
               </a:rPr>
-              <a:t>Samsung Display Vietnam (SDV) and DSC (China site). Korean SOP, local shop cards. Same rules on both sites.</a:t>
+              <a:t>Vietnam and China. Korean SOP, local shop cards. Same rules on both sites.</a:t>
             </a:r>
           </a:p>
         </p:txBody>
@@ -23412,7 +23412,7 @@
                 <a:latin typeface="Calibri"/>
                 <a:ea typeface="Calibri"/>
               </a:rPr>
-              <a:t>Sites and forms</a:t>
+              <a:t>Forms and inspection</a:t>
             </a:r>
           </a:p>
         </p:txBody>
@@ -23478,40 +23478,6 @@
             <a:spAutoFit/>
           </a:bodyPr>
           <a:lstStyle/>
-          <a:p>
-            <a:pPr>
-              <a:spcAft>
-                <a:spcPts val="800"/>
-              </a:spcAft>
-            </a:pPr>
-            <a:r>
-              <a:rPr sz="1400" b="0">
-                <a:solidFill>
-                  <a:srgbClr val="141820"/>
-                </a:solidFill>
-                <a:latin typeface="Calibri"/>
-                <a:ea typeface="Calibri"/>
-              </a:rPr>
-              <a:t>•  SDV — Samsung Display Vietnam.</a:t>
-            </a:r>
-          </a:p>
-          <a:p>
-            <a:pPr>
-              <a:spcAft>
-                <a:spcPts val="800"/>
-              </a:spcAft>
-            </a:pPr>
-            <a:r>
-              <a:rPr sz="1400" b="0">
-                <a:solidFill>
-                  <a:srgbClr val="141820"/>
-                </a:solidFill>
-                <a:latin typeface="Calibri"/>
-                <a:ea typeface="Calibri"/>
-              </a:rPr>
-              <a:t>•  DSC — China site.</a:t>
-            </a:r>
-          </a:p>
           <a:p>
             <a:pPr>
               <a:spcAft>

</xml_diff>

<commit_message>
Audience: CS and analysis engineers; copy polish EN/KO/ZH/VI
</commit_message>
<xml_diff>
--- a/Display-AI-Briefing-SDV-DSC.pptx
+++ b/Display-AI-Briefing-SDV-DSC.pptx
@@ -3374,7 +3374,7 @@
                 <a:latin typeface="Calibri"/>
                 <a:ea typeface="Calibri"/>
               </a:rPr>
-              <a:t>Quality engineers at SDV and DSC  ·  not AI researchers</a:t>
+              <a:t>CS and analysis engineers at SDV and DSC  ·  not AI researchers</a:t>
             </a:r>
           </a:p>
           <a:p>
@@ -11290,7 +11290,7 @@
                 <a:latin typeface="Calibri"/>
                 <a:ea typeface="Calibri"/>
               </a:rPr>
-              <a:t>Vietnam and China. Korean SOP, local shop cards. Same rules on both sites.</a:t>
+              <a:t>Customer Service (CS) and analysis engineers at the Vietnam and China sites. Korean SOP, local shop cards. Same rules on both sites.</a:t>
             </a:r>
           </a:p>
         </p:txBody>

</xml_diff>

<commit_message>
Trim who-card and drop editor-facing copy
</commit_message>
<xml_diff>
--- a/Display-AI-Briefing-SDV-DSC.pptx
+++ b/Display-AI-Briefing-SDV-DSC.pptx
@@ -11290,7 +11290,7 @@
                 <a:latin typeface="Calibri"/>
                 <a:ea typeface="Calibri"/>
               </a:rPr>
-              <a:t>Customer Service (CS) and analysis engineers at the Vietnam and China sites. Korean SOP, local shop cards. Same rules on both sites.</a:t>
+              <a:t>Customer Service (CS) and analysis engineers at the Vietnam and China sites.</a:t>
             </a:r>
           </a:p>
         </p:txBody>
@@ -18623,7 +18623,7 @@
                 <a:latin typeface="Calibri"/>
                 <a:ea typeface="Calibri"/>
               </a:rPr>
-              <a:t>Vision setup measurement. 2:30 → 10 s. ML / computer vision. Know this one at SDV.</a:t>
+              <a:t>Vision setup measurement. 2:30 → 10 s. ML / computer vision.</a:t>
             </a:r>
           </a:p>
         </p:txBody>

</xml_diff>